<commit_message>
Remove speaker notes from presentation slides
Presentation now contains 8 slides with:
- Professional corporate formatting
- All embedded figures and charts
- No speaker notes (cleaner for viewer mode)
</commit_message>
<xml_diff>
--- a/presentation_deck.pptx
+++ b/presentation_deck.pptx
@@ -7,12 +7,12 @@
   <p:sldIdLst>
     <p:sldId id="256" r:id="rId7"/>
     <p:sldId id="257" r:id="rId8"/>
-    <p:sldId id="258" r:id="rId10"/>
-    <p:sldId id="259" r:id="rId11"/>
-    <p:sldId id="260" r:id="rId12"/>
-    <p:sldId id="261" r:id="rId13"/>
-    <p:sldId id="262" r:id="rId14"/>
-    <p:sldId id="263" r:id="rId15"/>
+    <p:sldId id="258" r:id="rId9"/>
+    <p:sldId id="259" r:id="rId10"/>
+    <p:sldId id="260" r:id="rId11"/>
+    <p:sldId id="261" r:id="rId12"/>
+    <p:sldId id="262" r:id="rId13"/>
+    <p:sldId id="263" r:id="rId14"/>
   </p:sldIdLst>
   <p:sldSz cx="9144000" cy="6858000" type="screen4x3"/>
   <p:notesSz cx="6858000" cy="9144000"/>
@@ -112,846 +112,6 @@
     </a:lvl9pPr>
   </p:defaultTextStyle>
 </p:presentation>
-</file>
-
-<file path=ppt/notesMasters/notesMaster1.xml><?xml version="1.0" encoding="utf-8"?>
-<p:notesMaster xmlns:a="http://schemas.openxmlformats.org/drawingml/2006/main" xmlns:p="http://schemas.openxmlformats.org/presentationml/2006/main" xmlns:r="http://schemas.openxmlformats.org/officeDocument/2006/relationships">
-  <p:cSld>
-    <p:bg>
-      <p:bgRef idx="1001">
-        <a:schemeClr val="bg1"/>
-      </p:bgRef>
-    </p:bg>
-    <p:spTree>
-      <p:nvGrpSpPr>
-        <p:cNvPr id="1" name=""/>
-        <p:cNvGrpSpPr/>
-        <p:nvPr/>
-      </p:nvGrpSpPr>
-      <p:grpSpPr>
-        <a:xfrm>
-          <a:off x="0" y="0"/>
-          <a:ext cx="0" cy="0"/>
-          <a:chOff x="0" y="0"/>
-          <a:chExt cx="0" cy="0"/>
-        </a:xfrm>
-      </p:grpSpPr>
-      <p:sp>
-        <p:nvSpPr>
-          <p:cNvPr id="2" name="Header Placeholder 1"/>
-          <p:cNvSpPr>
-            <a:spLocks noGrp="1"/>
-          </p:cNvSpPr>
-          <p:nvPr>
-            <p:ph type="hdr" sz="quarter"/>
-          </p:nvPr>
-        </p:nvSpPr>
-        <p:spPr>
-          <a:xfrm>
-            <a:off x="0" y="0"/>
-            <a:ext cx="2971800" cy="457200"/>
-          </a:xfrm>
-          <a:prstGeom prst="rect">
-            <a:avLst/>
-          </a:prstGeom>
-        </p:spPr>
-        <p:txBody>
-          <a:bodyPr vert="horz" lIns="91440" tIns="45720" rIns="91440" bIns="45720" rtlCol="0"/>
-          <a:lstStyle>
-            <a:lvl1pPr algn="l">
-              <a:defRPr sz="1200"/>
-            </a:lvl1pPr>
-          </a:lstStyle>
-          <a:p>
-            <a:endParaRPr lang="en-US"/>
-          </a:p>
-        </p:txBody>
-      </p:sp>
-      <p:sp>
-        <p:nvSpPr>
-          <p:cNvPr id="3" name="Date Placeholder 2"/>
-          <p:cNvSpPr>
-            <a:spLocks noGrp="1"/>
-          </p:cNvSpPr>
-          <p:nvPr>
-            <p:ph type="dt" idx="1"/>
-          </p:nvPr>
-        </p:nvSpPr>
-        <p:spPr>
-          <a:xfrm>
-            <a:off x="3884613" y="0"/>
-            <a:ext cx="2971800" cy="457200"/>
-          </a:xfrm>
-          <a:prstGeom prst="rect">
-            <a:avLst/>
-          </a:prstGeom>
-        </p:spPr>
-        <p:txBody>
-          <a:bodyPr vert="horz" lIns="91440" tIns="45720" rIns="91440" bIns="45720" rtlCol="0"/>
-          <a:lstStyle>
-            <a:lvl1pPr algn="r">
-              <a:defRPr sz="1200"/>
-            </a:lvl1pPr>
-          </a:lstStyle>
-          <a:p>
-            <a:fld id="{0F89C1C7-3DCD-1040-A9CF-14679D8B5DDD}" type="datetimeFigureOut">
-              <a:rPr lang="en-US" smtClean="0"/>
-              <a:t>10/17/16</a:t>
-            </a:fld>
-            <a:endParaRPr lang="en-US"/>
-          </a:p>
-        </p:txBody>
-      </p:sp>
-      <p:sp>
-        <p:nvSpPr>
-          <p:cNvPr id="4" name="Slide Image Placeholder 3"/>
-          <p:cNvSpPr>
-            <a:spLocks noGrp="1" noRot="1" noChangeAspect="1"/>
-          </p:cNvSpPr>
-          <p:nvPr>
-            <p:ph type="sldImg" idx="2"/>
-          </p:nvPr>
-        </p:nvSpPr>
-        <p:spPr>
-          <a:xfrm>
-            <a:off x="1143000" y="685800"/>
-            <a:ext cx="4572000" cy="3429000"/>
-          </a:xfrm>
-          <a:prstGeom prst="rect">
-            <a:avLst/>
-          </a:prstGeom>
-          <a:noFill/>
-          <a:ln w="12700">
-            <a:solidFill>
-              <a:prstClr val="black"/>
-            </a:solidFill>
-          </a:ln>
-        </p:spPr>
-        <p:txBody>
-          <a:bodyPr vert="horz" lIns="91440" tIns="45720" rIns="91440" bIns="45720" rtlCol="0" anchor="ctr"/>
-          <a:lstStyle/>
-          <a:p>
-            <a:endParaRPr lang="en-US"/>
-          </a:p>
-        </p:txBody>
-      </p:sp>
-      <p:sp>
-        <p:nvSpPr>
-          <p:cNvPr id="5" name="Notes Placeholder 4"/>
-          <p:cNvSpPr>
-            <a:spLocks noGrp="1"/>
-          </p:cNvSpPr>
-          <p:nvPr>
-            <p:ph type="body" sz="quarter" idx="3"/>
-          </p:nvPr>
-        </p:nvSpPr>
-        <p:spPr>
-          <a:xfrm>
-            <a:off x="685800" y="4343400"/>
-            <a:ext cx="5486400" cy="4114800"/>
-          </a:xfrm>
-          <a:prstGeom prst="rect">
-            <a:avLst/>
-          </a:prstGeom>
-        </p:spPr>
-        <p:txBody>
-          <a:bodyPr vert="horz" lIns="91440" tIns="45720" rIns="91440" bIns="45720" rtlCol="0"/>
-          <a:lstStyle/>
-          <a:p>
-            <a:pPr lvl="0"/>
-            <a:r>
-              <a:rPr lang="en-US" smtClean="0"/>
-              <a:t>Click to edit Master text styles</a:t>
-            </a:r>
-          </a:p>
-          <a:p>
-            <a:pPr lvl="1"/>
-            <a:r>
-              <a:rPr lang="en-US" smtClean="0"/>
-              <a:t>Second level</a:t>
-            </a:r>
-          </a:p>
-          <a:p>
-            <a:pPr lvl="2"/>
-            <a:r>
-              <a:rPr lang="en-US" smtClean="0"/>
-              <a:t>Third level</a:t>
-            </a:r>
-          </a:p>
-          <a:p>
-            <a:pPr lvl="3"/>
-            <a:r>
-              <a:rPr lang="en-US" smtClean="0"/>
-              <a:t>Fourth level</a:t>
-            </a:r>
-          </a:p>
-          <a:p>
-            <a:pPr lvl="4"/>
-            <a:r>
-              <a:rPr lang="en-US" smtClean="0"/>
-              <a:t>Fifth level</a:t>
-            </a:r>
-            <a:endParaRPr lang="en-US"/>
-          </a:p>
-        </p:txBody>
-      </p:sp>
-      <p:sp>
-        <p:nvSpPr>
-          <p:cNvPr id="6" name="Footer Placeholder 5"/>
-          <p:cNvSpPr>
-            <a:spLocks noGrp="1"/>
-          </p:cNvSpPr>
-          <p:nvPr>
-            <p:ph type="ftr" sz="quarter" idx="4"/>
-          </p:nvPr>
-        </p:nvSpPr>
-        <p:spPr>
-          <a:xfrm>
-            <a:off x="0" y="8685213"/>
-            <a:ext cx="2971800" cy="457200"/>
-          </a:xfrm>
-          <a:prstGeom prst="rect">
-            <a:avLst/>
-          </a:prstGeom>
-        </p:spPr>
-        <p:txBody>
-          <a:bodyPr vert="horz" lIns="91440" tIns="45720" rIns="91440" bIns="45720" rtlCol="0" anchor="b"/>
-          <a:lstStyle>
-            <a:lvl1pPr algn="l">
-              <a:defRPr sz="1200"/>
-            </a:lvl1pPr>
-          </a:lstStyle>
-          <a:p>
-            <a:endParaRPr lang="en-US"/>
-          </a:p>
-        </p:txBody>
-      </p:sp>
-      <p:sp>
-        <p:nvSpPr>
-          <p:cNvPr id="7" name="Slide Number Placeholder 6"/>
-          <p:cNvSpPr>
-            <a:spLocks noGrp="1"/>
-          </p:cNvSpPr>
-          <p:nvPr>
-            <p:ph type="sldNum" sz="quarter" idx="5"/>
-          </p:nvPr>
-        </p:nvSpPr>
-        <p:spPr>
-          <a:xfrm>
-            <a:off x="3884613" y="8685213"/>
-            <a:ext cx="2971800" cy="457200"/>
-          </a:xfrm>
-          <a:prstGeom prst="rect">
-            <a:avLst/>
-          </a:prstGeom>
-        </p:spPr>
-        <p:txBody>
-          <a:bodyPr vert="horz" lIns="91440" tIns="45720" rIns="91440" bIns="45720" rtlCol="0" anchor="b"/>
-          <a:lstStyle>
-            <a:lvl1pPr algn="r">
-              <a:defRPr sz="1200"/>
-            </a:lvl1pPr>
-          </a:lstStyle>
-          <a:p>
-            <a:fld id="{BB5E49A5-4136-284D-997B-48E1D791AD67}" type="slidenum">
-              <a:rPr lang="en-US" smtClean="0"/>
-              <a:t>‹#›</a:t>
-            </a:fld>
-            <a:endParaRPr lang="en-US"/>
-          </a:p>
-        </p:txBody>
-      </p:sp>
-    </p:spTree>
-    <p:extLst>
-      <p:ext uri="{BB962C8B-B14F-4D97-AF65-F5344CB8AC3E}">
-        <p14:creationId xmlns:p14="http://schemas.microsoft.com/office/powerpoint/2010/main" val="2623252185"/>
-      </p:ext>
-    </p:extLst>
-  </p:cSld>
-  <p:clrMap bg1="lt1" tx1="dk1" bg2="lt2" tx2="dk2" accent1="accent1" accent2="accent2" accent3="accent3" accent4="accent4" accent5="accent5" accent6="accent6" hlink="hlink" folHlink="folHlink"/>
-  <p:notesStyle>
-    <a:lvl1pPr marL="0" algn="l" defTabSz="457200" rtl="0" eaLnBrk="1" latinLnBrk="0" hangingPunct="1">
-      <a:defRPr sz="1200" kern="1200">
-        <a:solidFill>
-          <a:schemeClr val="tx1"/>
-        </a:solidFill>
-        <a:latin typeface="+mn-lt"/>
-        <a:ea typeface="+mn-ea"/>
-        <a:cs typeface="+mn-cs"/>
-      </a:defRPr>
-    </a:lvl1pPr>
-    <a:lvl2pPr marL="457200" algn="l" defTabSz="457200" rtl="0" eaLnBrk="1" latinLnBrk="0" hangingPunct="1">
-      <a:defRPr sz="1200" kern="1200">
-        <a:solidFill>
-          <a:schemeClr val="tx1"/>
-        </a:solidFill>
-        <a:latin typeface="+mn-lt"/>
-        <a:ea typeface="+mn-ea"/>
-        <a:cs typeface="+mn-cs"/>
-      </a:defRPr>
-    </a:lvl2pPr>
-    <a:lvl3pPr marL="914400" algn="l" defTabSz="457200" rtl="0" eaLnBrk="1" latinLnBrk="0" hangingPunct="1">
-      <a:defRPr sz="1200" kern="1200">
-        <a:solidFill>
-          <a:schemeClr val="tx1"/>
-        </a:solidFill>
-        <a:latin typeface="+mn-lt"/>
-        <a:ea typeface="+mn-ea"/>
-        <a:cs typeface="+mn-cs"/>
-      </a:defRPr>
-    </a:lvl3pPr>
-    <a:lvl4pPr marL="1371600" algn="l" defTabSz="457200" rtl="0" eaLnBrk="1" latinLnBrk="0" hangingPunct="1">
-      <a:defRPr sz="1200" kern="1200">
-        <a:solidFill>
-          <a:schemeClr val="tx1"/>
-        </a:solidFill>
-        <a:latin typeface="+mn-lt"/>
-        <a:ea typeface="+mn-ea"/>
-        <a:cs typeface="+mn-cs"/>
-      </a:defRPr>
-    </a:lvl4pPr>
-    <a:lvl5pPr marL="1828800" algn="l" defTabSz="457200" rtl="0" eaLnBrk="1" latinLnBrk="0" hangingPunct="1">
-      <a:defRPr sz="1200" kern="1200">
-        <a:solidFill>
-          <a:schemeClr val="tx1"/>
-        </a:solidFill>
-        <a:latin typeface="+mn-lt"/>
-        <a:ea typeface="+mn-ea"/>
-        <a:cs typeface="+mn-cs"/>
-      </a:defRPr>
-    </a:lvl5pPr>
-    <a:lvl6pPr marL="2286000" algn="l" defTabSz="457200" rtl="0" eaLnBrk="1" latinLnBrk="0" hangingPunct="1">
-      <a:defRPr sz="1200" kern="1200">
-        <a:solidFill>
-          <a:schemeClr val="tx1"/>
-        </a:solidFill>
-        <a:latin typeface="+mn-lt"/>
-        <a:ea typeface="+mn-ea"/>
-        <a:cs typeface="+mn-cs"/>
-      </a:defRPr>
-    </a:lvl6pPr>
-    <a:lvl7pPr marL="2743200" algn="l" defTabSz="457200" rtl="0" eaLnBrk="1" latinLnBrk="0" hangingPunct="1">
-      <a:defRPr sz="1200" kern="1200">
-        <a:solidFill>
-          <a:schemeClr val="tx1"/>
-        </a:solidFill>
-        <a:latin typeface="+mn-lt"/>
-        <a:ea typeface="+mn-ea"/>
-        <a:cs typeface="+mn-cs"/>
-      </a:defRPr>
-    </a:lvl7pPr>
-    <a:lvl8pPr marL="3200400" algn="l" defTabSz="457200" rtl="0" eaLnBrk="1" latinLnBrk="0" hangingPunct="1">
-      <a:defRPr sz="1200" kern="1200">
-        <a:solidFill>
-          <a:schemeClr val="tx1"/>
-        </a:solidFill>
-        <a:latin typeface="+mn-lt"/>
-        <a:ea typeface="+mn-ea"/>
-        <a:cs typeface="+mn-cs"/>
-      </a:defRPr>
-    </a:lvl8pPr>
-    <a:lvl9pPr marL="3657600" algn="l" defTabSz="457200" rtl="0" eaLnBrk="1" latinLnBrk="0" hangingPunct="1">
-      <a:defRPr sz="1200" kern="1200">
-        <a:solidFill>
-          <a:schemeClr val="tx1"/>
-        </a:solidFill>
-        <a:latin typeface="+mn-lt"/>
-        <a:ea typeface="+mn-ea"/>
-        <a:cs typeface="+mn-cs"/>
-      </a:defRPr>
-    </a:lvl9pPr>
-  </p:notesStyle>
-</p:notesMaster>
-</file>
-
-<file path=ppt/notesSlides/notesSlide1.xml><?xml version="1.0" encoding="utf-8"?>
-<p:notes xmlns:a="http://schemas.openxmlformats.org/drawingml/2006/main" xmlns:p="http://schemas.openxmlformats.org/presentationml/2006/main" xmlns:r="http://schemas.openxmlformats.org/officeDocument/2006/relationships">
-  <p:cSld>
-    <p:spTree>
-      <p:nvGrpSpPr>
-        <p:cNvPr id="1" name=""/>
-        <p:cNvGrpSpPr/>
-        <p:nvPr/>
-      </p:nvGrpSpPr>
-      <p:grpSpPr>
-        <a:xfrm>
-          <a:off x="0" y="0"/>
-          <a:ext cx="0" cy="0"/>
-          <a:chOff x="0" y="0"/>
-          <a:chExt cx="0" cy="0"/>
-        </a:xfrm>
-      </p:grpSpPr>
-      <p:sp>
-        <p:nvSpPr>
-          <p:cNvPr id="2" name="Slide Image Placeholder 1"/>
-          <p:cNvSpPr>
-            <a:spLocks noGrp="1"/>
-          </p:cNvSpPr>
-          <p:nvPr>
-            <p:ph type="sldImg" idx="2"/>
-          </p:nvPr>
-        </p:nvSpPr>
-        <p:spPr/>
-      </p:sp>
-      <p:sp>
-        <p:nvSpPr>
-          <p:cNvPr id="3" name="Notes Placeholder 2"/>
-          <p:cNvSpPr>
-            <a:spLocks noGrp="1"/>
-          </p:cNvSpPr>
-          <p:nvPr>
-            <p:ph type="body" idx="3" sz="quarter"/>
-          </p:nvPr>
-        </p:nvSpPr>
-        <p:spPr/>
-        <p:txBody>
-          <a:bodyPr/>
-          <a:lstStyle/>
-          <a:p>
-            <a:r>
-              <a:t>Dataset includes 2,000 SME applications across Ghana. Default rates vary significantly by sector. The cost asymmetry between false positives and false negatives is critical—declining a good borrower (false positive) costs more than approving a bad one (false negative). This 10:1 ratio drives our decision threshold optimization.</a:t>
-            </a:r>
-          </a:p>
-        </p:txBody>
-      </p:sp>
-      <p:sp>
-        <p:nvSpPr>
-          <p:cNvPr id="4" name="Slide Number Placeholder 3"/>
-          <p:cNvSpPr>
-            <a:spLocks noGrp="1"/>
-          </p:cNvSpPr>
-          <p:nvPr>
-            <p:ph type="sldNum" idx="5" sz="quarter"/>
-          </p:nvPr>
-        </p:nvSpPr>
-        <p:spPr/>
-      </p:sp>
-    </p:spTree>
-  </p:cSld>
-  <p:clrMapOvr>
-    <a:masterClrMapping/>
-  </p:clrMapOvr>
-</p:notes>
-</file>
-
-<file path=ppt/notesSlides/notesSlide2.xml><?xml version="1.0" encoding="utf-8"?>
-<p:notes xmlns:a="http://schemas.openxmlformats.org/drawingml/2006/main" xmlns:p="http://schemas.openxmlformats.org/presentationml/2006/main" xmlns:r="http://schemas.openxmlformats.org/officeDocument/2006/relationships">
-  <p:cSld>
-    <p:spTree>
-      <p:nvGrpSpPr>
-        <p:cNvPr id="1" name=""/>
-        <p:cNvGrpSpPr/>
-        <p:nvPr/>
-      </p:nvGrpSpPr>
-      <p:grpSpPr>
-        <a:xfrm>
-          <a:off x="0" y="0"/>
-          <a:ext cx="0" cy="0"/>
-          <a:chOff x="0" y="0"/>
-          <a:chExt cx="0" cy="0"/>
-        </a:xfrm>
-      </p:grpSpPr>
-      <p:sp>
-        <p:nvSpPr>
-          <p:cNvPr id="2" name="Slide Image Placeholder 1"/>
-          <p:cNvSpPr>
-            <a:spLocks noGrp="1"/>
-          </p:cNvSpPr>
-          <p:nvPr>
-            <p:ph type="sldImg" idx="2"/>
-          </p:nvPr>
-        </p:nvSpPr>
-        <p:spPr/>
-      </p:sp>
-      <p:sp>
-        <p:nvSpPr>
-          <p:cNvPr id="3" name="Notes Placeholder 2"/>
-          <p:cNvSpPr>
-            <a:spLocks noGrp="1"/>
-          </p:cNvSpPr>
-          <p:nvPr>
-            <p:ph type="body" idx="3" sz="quarter"/>
-          </p:nvPr>
-        </p:nvSpPr>
-        <p:spPr/>
-        <p:txBody>
-          <a:bodyPr/>
-          <a:lstStyle/>
-          <a:p>
-            <a:r>
-              <a:t>During EDA, we detected significant missing data patterns that could indicate leakage. Instead of just imputing, we investigated root causes and found systematic collection gaps. We excluded these records to prevent leakage, ensuring the model learns from clean data.</a:t>
-            </a:r>
-          </a:p>
-        </p:txBody>
-      </p:sp>
-      <p:sp>
-        <p:nvSpPr>
-          <p:cNvPr id="4" name="Slide Number Placeholder 3"/>
-          <p:cNvSpPr>
-            <a:spLocks noGrp="1"/>
-          </p:cNvSpPr>
-          <p:nvPr>
-            <p:ph type="sldNum" idx="5" sz="quarter"/>
-          </p:nvPr>
-        </p:nvSpPr>
-        <p:spPr/>
-      </p:sp>
-    </p:spTree>
-  </p:cSld>
-  <p:clrMapOvr>
-    <a:masterClrMapping/>
-  </p:clrMapOvr>
-</p:notes>
-</file>
-
-<file path=ppt/notesSlides/notesSlide3.xml><?xml version="1.0" encoding="utf-8"?>
-<p:notes xmlns:a="http://schemas.openxmlformats.org/drawingml/2006/main" xmlns:p="http://schemas.openxmlformats.org/presentationml/2006/main" xmlns:r="http://schemas.openxmlformats.org/officeDocument/2006/relationships">
-  <p:cSld>
-    <p:spTree>
-      <p:nvGrpSpPr>
-        <p:cNvPr id="1" name=""/>
-        <p:cNvGrpSpPr/>
-        <p:nvPr/>
-      </p:nvGrpSpPr>
-      <p:grpSpPr>
-        <a:xfrm>
-          <a:off x="0" y="0"/>
-          <a:ext cx="0" cy="0"/>
-          <a:chOff x="0" y="0"/>
-          <a:chExt cx="0" cy="0"/>
-        </a:xfrm>
-      </p:grpSpPr>
-      <p:sp>
-        <p:nvSpPr>
-          <p:cNvPr id="2" name="Slide Image Placeholder 1"/>
-          <p:cNvSpPr>
-            <a:spLocks noGrp="1"/>
-          </p:cNvSpPr>
-          <p:nvPr>
-            <p:ph type="sldImg" idx="2"/>
-          </p:nvPr>
-        </p:nvSpPr>
-        <p:spPr/>
-      </p:sp>
-      <p:sp>
-        <p:nvSpPr>
-          <p:cNvPr id="3" name="Notes Placeholder 2"/>
-          <p:cNvSpPr>
-            <a:spLocks noGrp="1"/>
-          </p:cNvSpPr>
-          <p:nvPr>
-            <p:ph type="body" idx="3" sz="quarter"/>
-          </p:nvPr>
-        </p:nvSpPr>
-        <p:spPr/>
-        <p:txBody>
-          <a:bodyPr/>
-          <a:lstStyle/>
-          <a:p>
-            <a:r>
-              <a:t>We engineered 41 features in three categories: numeric (revenue metrics, ratios), categorical (sector, region), and binary (credit defects, collateral). Features were designed to capture domain knowledge while avoiding multicollinearity. SHAP analysis validated feature importance.</a:t>
-            </a:r>
-          </a:p>
-        </p:txBody>
-      </p:sp>
-      <p:sp>
-        <p:nvSpPr>
-          <p:cNvPr id="4" name="Slide Number Placeholder 3"/>
-          <p:cNvSpPr>
-            <a:spLocks noGrp="1"/>
-          </p:cNvSpPr>
-          <p:nvPr>
-            <p:ph type="sldNum" idx="5" sz="quarter"/>
-          </p:nvPr>
-        </p:nvSpPr>
-        <p:spPr/>
-      </p:sp>
-    </p:spTree>
-  </p:cSld>
-  <p:clrMapOvr>
-    <a:masterClrMapping/>
-  </p:clrMapOvr>
-</p:notes>
-</file>
-
-<file path=ppt/notesSlides/notesSlide4.xml><?xml version="1.0" encoding="utf-8"?>
-<p:notes xmlns:a="http://schemas.openxmlformats.org/drawingml/2006/main" xmlns:p="http://schemas.openxmlformats.org/presentationml/2006/main" xmlns:r="http://schemas.openxmlformats.org/officeDocument/2006/relationships">
-  <p:cSld>
-    <p:spTree>
-      <p:nvGrpSpPr>
-        <p:cNvPr id="1" name=""/>
-        <p:cNvGrpSpPr/>
-        <p:nvPr/>
-      </p:nvGrpSpPr>
-      <p:grpSpPr>
-        <a:xfrm>
-          <a:off x="0" y="0"/>
-          <a:ext cx="0" cy="0"/>
-          <a:chOff x="0" y="0"/>
-          <a:chExt cx="0" cy="0"/>
-        </a:xfrm>
-      </p:grpSpPr>
-      <p:sp>
-        <p:nvSpPr>
-          <p:cNvPr id="2" name="Slide Image Placeholder 1"/>
-          <p:cNvSpPr>
-            <a:spLocks noGrp="1"/>
-          </p:cNvSpPr>
-          <p:nvPr>
-            <p:ph type="sldImg" idx="2"/>
-          </p:nvPr>
-        </p:nvSpPr>
-        <p:spPr/>
-      </p:sp>
-      <p:sp>
-        <p:nvSpPr>
-          <p:cNvPr id="3" name="Notes Placeholder 2"/>
-          <p:cNvSpPr>
-            <a:spLocks noGrp="1"/>
-          </p:cNvSpPr>
-          <p:nvPr>
-            <p:ph type="body" idx="3" sz="quarter"/>
-          </p:nvPr>
-        </p:nvSpPr>
-        <p:spPr/>
-        <p:txBody>
-          <a:bodyPr/>
-          <a:lstStyle/>
-          <a:p>
-            <a:r>
-              <a:t>All models were trained with 5-fold cross-validation. Logistic Regression won despite lower absolute AUC because it offers superior interpretability for regulatory compliance and fairer predictions across demographic groups. Gini coefficients show model discrimination ability.</a:t>
-            </a:r>
-          </a:p>
-        </p:txBody>
-      </p:sp>
-      <p:sp>
-        <p:nvSpPr>
-          <p:cNvPr id="4" name="Slide Number Placeholder 3"/>
-          <p:cNvSpPr>
-            <a:spLocks noGrp="1"/>
-          </p:cNvSpPr>
-          <p:nvPr>
-            <p:ph type="sldNum" idx="5" sz="quarter"/>
-          </p:nvPr>
-        </p:nvSpPr>
-        <p:spPr/>
-      </p:sp>
-    </p:spTree>
-  </p:cSld>
-  <p:clrMapOvr>
-    <a:masterClrMapping/>
-  </p:clrMapOvr>
-</p:notes>
-</file>
-
-<file path=ppt/notesSlides/notesSlide5.xml><?xml version="1.0" encoding="utf-8"?>
-<p:notes xmlns:a="http://schemas.openxmlformats.org/drawingml/2006/main" xmlns:p="http://schemas.openxmlformats.org/presentationml/2006/main" xmlns:r="http://schemas.openxmlformats.org/officeDocument/2006/relationships">
-  <p:cSld>
-    <p:spTree>
-      <p:nvGrpSpPr>
-        <p:cNvPr id="1" name=""/>
-        <p:cNvGrpSpPr/>
-        <p:nvPr/>
-      </p:nvGrpSpPr>
-      <p:grpSpPr>
-        <a:xfrm>
-          <a:off x="0" y="0"/>
-          <a:ext cx="0" cy="0"/>
-          <a:chOff x="0" y="0"/>
-          <a:chExt cx="0" cy="0"/>
-        </a:xfrm>
-      </p:grpSpPr>
-      <p:sp>
-        <p:nvSpPr>
-          <p:cNvPr id="2" name="Slide Image Placeholder 1"/>
-          <p:cNvSpPr>
-            <a:spLocks noGrp="1"/>
-          </p:cNvSpPr>
-          <p:nvPr>
-            <p:ph type="sldImg" idx="2"/>
-          </p:nvPr>
-        </p:nvSpPr>
-        <p:spPr/>
-      </p:sp>
-      <p:sp>
-        <p:nvSpPr>
-          <p:cNvPr id="3" name="Notes Placeholder 2"/>
-          <p:cNvSpPr>
-            <a:spLocks noGrp="1"/>
-          </p:cNvSpPr>
-          <p:nvPr>
-            <p:ph type="body" idx="3" sz="quarter"/>
-          </p:nvPr>
-        </p:nvSpPr>
-        <p:spPr/>
-        <p:txBody>
-          <a:bodyPr/>
-          <a:lstStyle/>
-          <a:p>
-            <a:r>
-              <a:t>The decision engine combines model scores with hard business rules. This three-tier framework (APPROVE/REFER/DECLINE) allows manual review of borderline cases, reducing false positives. Rules are derived from regulatory requirements and business constraints.</a:t>
-            </a:r>
-          </a:p>
-        </p:txBody>
-      </p:sp>
-      <p:sp>
-        <p:nvSpPr>
-          <p:cNvPr id="4" name="Slide Number Placeholder 3"/>
-          <p:cNvSpPr>
-            <a:spLocks noGrp="1"/>
-          </p:cNvSpPr>
-          <p:nvPr>
-            <p:ph type="sldNum" idx="5" sz="quarter"/>
-          </p:nvPr>
-        </p:nvSpPr>
-        <p:spPr/>
-      </p:sp>
-    </p:spTree>
-  </p:cSld>
-  <p:clrMapOvr>
-    <a:masterClrMapping/>
-  </p:clrMapOvr>
-</p:notes>
-</file>
-
-<file path=ppt/notesSlides/notesSlide6.xml><?xml version="1.0" encoding="utf-8"?>
-<p:notes xmlns:a="http://schemas.openxmlformats.org/drawingml/2006/main" xmlns:p="http://schemas.openxmlformats.org/presentationml/2006/main" xmlns:r="http://schemas.openxmlformats.org/officeDocument/2006/relationships">
-  <p:cSld>
-    <p:spTree>
-      <p:nvGrpSpPr>
-        <p:cNvPr id="1" name=""/>
-        <p:cNvGrpSpPr/>
-        <p:nvPr/>
-      </p:nvGrpSpPr>
-      <p:grpSpPr>
-        <a:xfrm>
-          <a:off x="0" y="0"/>
-          <a:ext cx="0" cy="0"/>
-          <a:chOff x="0" y="0"/>
-          <a:chExt cx="0" cy="0"/>
-        </a:xfrm>
-      </p:grpSpPr>
-      <p:sp>
-        <p:nvSpPr>
-          <p:cNvPr id="2" name="Slide Image Placeholder 1"/>
-          <p:cNvSpPr>
-            <a:spLocks noGrp="1"/>
-          </p:cNvSpPr>
-          <p:nvPr>
-            <p:ph type="sldImg" idx="2"/>
-          </p:nvPr>
-        </p:nvSpPr>
-        <p:spPr/>
-      </p:sp>
-      <p:sp>
-        <p:nvSpPr>
-          <p:cNvPr id="3" name="Notes Placeholder 2"/>
-          <p:cNvSpPr>
-            <a:spLocks noGrp="1"/>
-          </p:cNvSpPr>
-          <p:nvPr>
-            <p:ph type="body" idx="3" sz="quarter"/>
-          </p:nvPr>
-        </p:nvSpPr>
-        <p:spPr/>
-        <p:txBody>
-          <a:bodyPr/>
-          <a:lstStyle/>
-          <a:p>
-            <a:r>
-              <a:t>Fairness was built-in from the start, not added after. We calculated Disparate Impact Ratios for protected groups and verified all meet the 0.80 threshold. SHAP waterfall plots show feature contributions are fair across demographic groups.</a:t>
-            </a:r>
-          </a:p>
-        </p:txBody>
-      </p:sp>
-      <p:sp>
-        <p:nvSpPr>
-          <p:cNvPr id="4" name="Slide Number Placeholder 3"/>
-          <p:cNvSpPr>
-            <a:spLocks noGrp="1"/>
-          </p:cNvSpPr>
-          <p:nvPr>
-            <p:ph type="sldNum" idx="5" sz="quarter"/>
-          </p:nvPr>
-        </p:nvSpPr>
-        <p:spPr/>
-      </p:sp>
-    </p:spTree>
-  </p:cSld>
-  <p:clrMapOvr>
-    <a:masterClrMapping/>
-  </p:clrMapOvr>
-</p:notes>
-</file>
-
-<file path=ppt/notesSlides/notesSlide7.xml><?xml version="1.0" encoding="utf-8"?>
-<p:notes xmlns:a="http://schemas.openxmlformats.org/drawingml/2006/main" xmlns:p="http://schemas.openxmlformats.org/presentationml/2006/main" xmlns:r="http://schemas.openxmlformats.org/officeDocument/2006/relationships">
-  <p:cSld>
-    <p:spTree>
-      <p:nvGrpSpPr>
-        <p:cNvPr id="1" name=""/>
-        <p:cNvGrpSpPr/>
-        <p:nvPr/>
-      </p:nvGrpSpPr>
-      <p:grpSpPr>
-        <a:xfrm>
-          <a:off x="0" y="0"/>
-          <a:ext cx="0" cy="0"/>
-          <a:chOff x="0" y="0"/>
-          <a:chExt cx="0" cy="0"/>
-        </a:xfrm>
-      </p:grpSpPr>
-      <p:sp>
-        <p:nvSpPr>
-          <p:cNvPr id="2" name="Slide Image Placeholder 1"/>
-          <p:cNvSpPr>
-            <a:spLocks noGrp="1"/>
-          </p:cNvSpPr>
-          <p:nvPr>
-            <p:ph type="sldImg" idx="2"/>
-          </p:nvPr>
-        </p:nvSpPr>
-        <p:spPr/>
-      </p:sp>
-      <p:sp>
-        <p:nvSpPr>
-          <p:cNvPr id="3" name="Notes Placeholder 2"/>
-          <p:cNvSpPr>
-            <a:spLocks noGrp="1"/>
-          </p:cNvSpPr>
-          <p:nvPr>
-            <p:ph type="body" idx="3" sz="quarter"/>
-          </p:nvPr>
-        </p:nvSpPr>
-        <p:spPr/>
-        <p:txBody>
-          <a:bodyPr/>
-          <a:lstStyle/>
-          <a:p>
-            <a:r>
-              <a:t>The architecture is modular and production-ready. Each component (preprocessing, feature engineering, modeling, decision engine) is independently testable. Fairness auditing and explainability are integrated, not bolted on.</a:t>
-            </a:r>
-          </a:p>
-        </p:txBody>
-      </p:sp>
-      <p:sp>
-        <p:nvSpPr>
-          <p:cNvPr id="4" name="Slide Number Placeholder 3"/>
-          <p:cNvSpPr>
-            <a:spLocks noGrp="1"/>
-          </p:cNvSpPr>
-          <p:nvPr>
-            <p:ph type="sldNum" idx="5" sz="quarter"/>
-          </p:nvPr>
-        </p:nvSpPr>
-        <p:spPr/>
-      </p:sp>
-    </p:spTree>
-  </p:cSld>
-  <p:clrMapOvr>
-    <a:masterClrMapping/>
-  </p:clrMapOvr>
-</p:notes>
 </file>
 
 <file path=ppt/slideLayouts/slideLayout1.xml><?xml version="1.0" encoding="utf-8"?>
@@ -6018,324 +5178,4 @@
   </a:objectDefaults>
   <a:extraClrSchemeLst/>
 </a:theme>
-</file>
-
-<file path=ppt/theme/theme2.xml><?xml version="1.0" encoding="utf-8"?>
-<a:theme xmlns:a="http://schemas.openxmlformats.org/drawingml/2006/main" name="Office Theme">
-  <a:themeElements>
-    <a:clrScheme name="Office">
-      <a:dk1>
-        <a:sysClr val="windowText" lastClr="000000"/>
-      </a:dk1>
-      <a:lt1>
-        <a:sysClr val="window" lastClr="FFFFFF"/>
-      </a:lt1>
-      <a:dk2>
-        <a:srgbClr val="1F497D"/>
-      </a:dk2>
-      <a:lt2>
-        <a:srgbClr val="EEECE1"/>
-      </a:lt2>
-      <a:accent1>
-        <a:srgbClr val="4F81BD"/>
-      </a:accent1>
-      <a:accent2>
-        <a:srgbClr val="C0504D"/>
-      </a:accent2>
-      <a:accent3>
-        <a:srgbClr val="9BBB59"/>
-      </a:accent3>
-      <a:accent4>
-        <a:srgbClr val="8064A2"/>
-      </a:accent4>
-      <a:accent5>
-        <a:srgbClr val="4BACC6"/>
-      </a:accent5>
-      <a:accent6>
-        <a:srgbClr val="F79646"/>
-      </a:accent6>
-      <a:hlink>
-        <a:srgbClr val="0000FF"/>
-      </a:hlink>
-      <a:folHlink>
-        <a:srgbClr val="800080"/>
-      </a:folHlink>
-    </a:clrScheme>
-    <a:fontScheme name="Office">
-      <a:majorFont>
-        <a:latin typeface="Calibri"/>
-        <a:ea typeface=""/>
-        <a:cs typeface=""/>
-        <a:font script="Jpan" typeface="ＭＳ Ｐゴシック"/>
-        <a:font script="Hang" typeface="맑은 고딕"/>
-        <a:font script="Hans" typeface="宋体"/>
-        <a:font script="Hant" typeface="新細明體"/>
-        <a:font script="Arab" typeface="Times New Roman"/>
-        <a:font script="Hebr" typeface="Times New Roman"/>
-        <a:font script="Thai" typeface="Angsana New"/>
-        <a:font script="Ethi" typeface="Nyala"/>
-        <a:font script="Beng" typeface="Vrinda"/>
-        <a:font script="Gujr" typeface="Shruti"/>
-        <a:font script="Khmr" typeface="MoolBoran"/>
-        <a:font script="Knda" typeface="Tunga"/>
-        <a:font script="Guru" typeface="Raavi"/>
-        <a:font script="Cans" typeface="Euphemia"/>
-        <a:font script="Cher" typeface="Plantagenet Cherokee"/>
-        <a:font script="Yiii" typeface="Microsoft Yi Baiti"/>
-        <a:font script="Tibt" typeface="Microsoft Himalaya"/>
-        <a:font script="Thaa" typeface="MV Boli"/>
-        <a:font script="Deva" typeface="Mangal"/>
-        <a:font script="Telu" typeface="Gautami"/>
-        <a:font script="Taml" typeface="Latha"/>
-        <a:font script="Syrc" typeface="Estrangelo Edessa"/>
-        <a:font script="Orya" typeface="Kalinga"/>
-        <a:font script="Mlym" typeface="Kartika"/>
-        <a:font script="Laoo" typeface="DokChampa"/>
-        <a:font script="Sinh" typeface="Iskoola Pota"/>
-        <a:font script="Mong" typeface="Mongolian Baiti"/>
-        <a:font script="Viet" typeface="Times New Roman"/>
-        <a:font script="Uigh" typeface="Microsoft Uighur"/>
-        <a:font script="Geor" typeface="Sylfaen"/>
-      </a:majorFont>
-      <a:minorFont>
-        <a:latin typeface="Calibri"/>
-        <a:ea typeface=""/>
-        <a:cs typeface=""/>
-        <a:font script="Jpan" typeface="ＭＳ Ｐゴシック"/>
-        <a:font script="Hang" typeface="맑은 고딕"/>
-        <a:font script="Hans" typeface="宋体"/>
-        <a:font script="Hant" typeface="新細明體"/>
-        <a:font script="Arab" typeface="Arial"/>
-        <a:font script="Hebr" typeface="Arial"/>
-        <a:font script="Thai" typeface="Cordia New"/>
-        <a:font script="Ethi" typeface="Nyala"/>
-        <a:font script="Beng" typeface="Vrinda"/>
-        <a:font script="Gujr" typeface="Shruti"/>
-        <a:font script="Khmr" typeface="DaunPenh"/>
-        <a:font script="Knda" typeface="Tunga"/>
-        <a:font script="Guru" typeface="Raavi"/>
-        <a:font script="Cans" typeface="Euphemia"/>
-        <a:font script="Cher" typeface="Plantagenet Cherokee"/>
-        <a:font script="Yiii" typeface="Microsoft Yi Baiti"/>
-        <a:font script="Tibt" typeface="Microsoft Himalaya"/>
-        <a:font script="Thaa" typeface="MV Boli"/>
-        <a:font script="Deva" typeface="Mangal"/>
-        <a:font script="Telu" typeface="Gautami"/>
-        <a:font script="Taml" typeface="Latha"/>
-        <a:font script="Syrc" typeface="Estrangelo Edessa"/>
-        <a:font script="Orya" typeface="Kalinga"/>
-        <a:font script="Mlym" typeface="Kartika"/>
-        <a:font script="Laoo" typeface="DokChampa"/>
-        <a:font script="Sinh" typeface="Iskoola Pota"/>
-        <a:font script="Mong" typeface="Mongolian Baiti"/>
-        <a:font script="Viet" typeface="Arial"/>
-        <a:font script="Uigh" typeface="Microsoft Uighur"/>
-        <a:font script="Geor" typeface="Sylfaen"/>
-      </a:minorFont>
-    </a:fontScheme>
-    <a:fmtScheme name="Office">
-      <a:fillStyleLst>
-        <a:solidFill>
-          <a:schemeClr val="phClr"/>
-        </a:solidFill>
-        <a:gradFill rotWithShape="1">
-          <a:gsLst>
-            <a:gs pos="0">
-              <a:schemeClr val="phClr">
-                <a:tint val="50000"/>
-                <a:satMod val="300000"/>
-              </a:schemeClr>
-            </a:gs>
-            <a:gs pos="35000">
-              <a:schemeClr val="phClr">
-                <a:tint val="37000"/>
-                <a:satMod val="300000"/>
-              </a:schemeClr>
-            </a:gs>
-            <a:gs pos="100000">
-              <a:schemeClr val="phClr">
-                <a:tint val="15000"/>
-                <a:satMod val="350000"/>
-              </a:schemeClr>
-            </a:gs>
-          </a:gsLst>
-          <a:lin ang="16200000" scaled="1"/>
-        </a:gradFill>
-        <a:gradFill rotWithShape="1">
-          <a:gsLst>
-            <a:gs pos="0">
-              <a:schemeClr val="phClr">
-                <a:tint val="100000"/>
-                <a:shade val="100000"/>
-                <a:satMod val="130000"/>
-              </a:schemeClr>
-            </a:gs>
-            <a:gs pos="100000">
-              <a:schemeClr val="phClr">
-                <a:tint val="50000"/>
-                <a:shade val="100000"/>
-                <a:satMod val="350000"/>
-              </a:schemeClr>
-            </a:gs>
-          </a:gsLst>
-          <a:lin ang="16200000" scaled="0"/>
-        </a:gradFill>
-      </a:fillStyleLst>
-      <a:lnStyleLst>
-        <a:ln w="9525" cap="flat" cmpd="sng" algn="ctr">
-          <a:solidFill>
-            <a:schemeClr val="phClr">
-              <a:shade val="95000"/>
-              <a:satMod val="105000"/>
-            </a:schemeClr>
-          </a:solidFill>
-          <a:prstDash val="solid"/>
-        </a:ln>
-        <a:ln w="25400" cap="flat" cmpd="sng" algn="ctr">
-          <a:solidFill>
-            <a:schemeClr val="phClr"/>
-          </a:solidFill>
-          <a:prstDash val="solid"/>
-        </a:ln>
-        <a:ln w="38100" cap="flat" cmpd="sng" algn="ctr">
-          <a:solidFill>
-            <a:schemeClr val="phClr"/>
-          </a:solidFill>
-          <a:prstDash val="solid"/>
-        </a:ln>
-      </a:lnStyleLst>
-      <a:effectStyleLst>
-        <a:effectStyle>
-          <a:effectLst>
-            <a:outerShdw blurRad="40000" dist="20000" dir="5400000" rotWithShape="0">
-              <a:srgbClr val="000000">
-                <a:alpha val="38000"/>
-              </a:srgbClr>
-            </a:outerShdw>
-          </a:effectLst>
-        </a:effectStyle>
-        <a:effectStyle>
-          <a:effectLst>
-            <a:outerShdw blurRad="40000" dist="23000" dir="5400000" rotWithShape="0">
-              <a:srgbClr val="000000">
-                <a:alpha val="35000"/>
-              </a:srgbClr>
-            </a:outerShdw>
-          </a:effectLst>
-        </a:effectStyle>
-        <a:effectStyle>
-          <a:effectLst>
-            <a:outerShdw blurRad="40000" dist="23000" dir="5400000" rotWithShape="0">
-              <a:srgbClr val="000000">
-                <a:alpha val="35000"/>
-              </a:srgbClr>
-            </a:outerShdw>
-          </a:effectLst>
-          <a:scene3d>
-            <a:camera prst="orthographicFront">
-              <a:rot lat="0" lon="0" rev="0"/>
-            </a:camera>
-            <a:lightRig rig="threePt" dir="t">
-              <a:rot lat="0" lon="0" rev="1200000"/>
-            </a:lightRig>
-          </a:scene3d>
-          <a:sp3d>
-            <a:bevelT w="63500" h="25400"/>
-          </a:sp3d>
-        </a:effectStyle>
-      </a:effectStyleLst>
-      <a:bgFillStyleLst>
-        <a:solidFill>
-          <a:schemeClr val="phClr"/>
-        </a:solidFill>
-        <a:gradFill rotWithShape="1">
-          <a:gsLst>
-            <a:gs pos="0">
-              <a:schemeClr val="phClr">
-                <a:tint val="40000"/>
-                <a:satMod val="350000"/>
-              </a:schemeClr>
-            </a:gs>
-            <a:gs pos="40000">
-              <a:schemeClr val="phClr">
-                <a:tint val="45000"/>
-                <a:shade val="99000"/>
-                <a:satMod val="350000"/>
-              </a:schemeClr>
-            </a:gs>
-            <a:gs pos="100000">
-              <a:schemeClr val="phClr">
-                <a:shade val="20000"/>
-                <a:satMod val="255000"/>
-              </a:schemeClr>
-            </a:gs>
-          </a:gsLst>
-          <a:path path="circle">
-            <a:fillToRect l="50000" t="-80000" r="50000" b="180000"/>
-          </a:path>
-        </a:gradFill>
-        <a:gradFill rotWithShape="1">
-          <a:gsLst>
-            <a:gs pos="0">
-              <a:schemeClr val="phClr">
-                <a:tint val="80000"/>
-                <a:satMod val="300000"/>
-              </a:schemeClr>
-            </a:gs>
-            <a:gs pos="100000">
-              <a:schemeClr val="phClr">
-                <a:shade val="30000"/>
-                <a:satMod val="200000"/>
-              </a:schemeClr>
-            </a:gs>
-          </a:gsLst>
-          <a:path path="circle">
-            <a:fillToRect l="50000" t="50000" r="50000" b="50000"/>
-          </a:path>
-        </a:gradFill>
-      </a:bgFillStyleLst>
-    </a:fmtScheme>
-  </a:themeElements>
-  <a:objectDefaults>
-    <a:spDef>
-      <a:spPr/>
-      <a:bodyPr/>
-      <a:lstStyle/>
-      <a:style>
-        <a:lnRef idx="1">
-          <a:schemeClr val="accent1"/>
-        </a:lnRef>
-        <a:fillRef idx="3">
-          <a:schemeClr val="accent1"/>
-        </a:fillRef>
-        <a:effectRef idx="2">
-          <a:schemeClr val="accent1"/>
-        </a:effectRef>
-        <a:fontRef idx="minor">
-          <a:schemeClr val="lt1"/>
-        </a:fontRef>
-      </a:style>
-    </a:spDef>
-    <a:lnDef>
-      <a:spPr/>
-      <a:bodyPr/>
-      <a:lstStyle/>
-      <a:style>
-        <a:lnRef idx="2">
-          <a:schemeClr val="accent1"/>
-        </a:lnRef>
-        <a:fillRef idx="0">
-          <a:schemeClr val="accent1"/>
-        </a:fillRef>
-        <a:effectRef idx="1">
-          <a:schemeClr val="accent1"/>
-        </a:effectRef>
-        <a:fontRef idx="minor">
-          <a:schemeClr val="tx1"/>
-        </a:fontRef>
-      </a:style>
-    </a:lnDef>
-  </a:objectDefaults>
-  <a:extraClrSchemeLst/>
-</a:theme>
 </file>
</xml_diff>